<commit_message>
Generated Update from Main Repository
</commit_message>
<xml_diff>
--- a/reference_material/slides/011_Correlation_Scatter.pptx
+++ b/reference_material/slides/011_Correlation_Scatter.pptx
@@ -7891,15 +7891,7 @@
             <a:pPr lvl="1"/>
             <a:r>
               <a:rPr lang="en-US" dirty="0"/>
-              <a:t>Most </a:t>
-            </a:r>
-            <a:r>
-              <a:rPr lang="en-US"/>
-              <a:t>frequently just </a:t>
-            </a:r>
-            <a:r>
-              <a:rPr lang="en-US" dirty="0"/>
-              <a:t>identify correlation visually in exploration. </a:t>
+              <a:t>Most frequently just identify correlation visually in exploration. </a:t>
             </a:r>
           </a:p>
           <a:p>

</xml_diff>